<commit_message>
delete fucking stupid classwork
</commit_message>
<xml_diff>
--- a/ode1/102.pptx
+++ b/ode1/102.pptx
@@ -159,7 +159,7 @@
       </p:grpSpPr>
       <p:sp>
         <p:nvSpPr>
-          <p:cNvPr id="712083833" name="页眉占位符 1"/>
+          <p:cNvPr id="938000638" name="页眉占位符 1"/>
           <p:cNvSpPr>
             <a:spLocks noGrp="1"/>
           </p:cNvSpPr>
@@ -193,7 +193,7 @@
       </p:sp>
       <p:sp>
         <p:nvSpPr>
-          <p:cNvPr id="467905464" name="日期占位符 2"/>
+          <p:cNvPr id="482934175" name="日期占位符 2"/>
           <p:cNvSpPr>
             <a:spLocks noGrp="1"/>
           </p:cNvSpPr>
@@ -231,7 +231,7 @@
       </p:sp>
       <p:sp>
         <p:nvSpPr>
-          <p:cNvPr id="611262000" name="幻灯片图像占位符 3"/>
+          <p:cNvPr id="1033984230" name="幻灯片图像占位符 3"/>
           <p:cNvSpPr>
             <a:spLocks noChangeAspect="1" noGrp="1" noRot="1"/>
           </p:cNvSpPr>
@@ -267,7 +267,7 @@
       </p:sp>
       <p:sp>
         <p:nvSpPr>
-          <p:cNvPr id="1680491352" name="备注占位符 4"/>
+          <p:cNvPr id="1770072958" name="备注占位符 4"/>
           <p:cNvSpPr>
             <a:spLocks noGrp="1"/>
           </p:cNvSpPr>
@@ -341,7 +341,7 @@
       </p:sp>
       <p:sp>
         <p:nvSpPr>
-          <p:cNvPr id="1525076077" name="页脚占位符 5"/>
+          <p:cNvPr id="1857095033" name="页脚占位符 5"/>
           <p:cNvSpPr>
             <a:spLocks noGrp="1"/>
           </p:cNvSpPr>
@@ -375,7 +375,7 @@
       </p:sp>
       <p:sp>
         <p:nvSpPr>
-          <p:cNvPr id="616482874" name="灯片编号占位符 6"/>
+          <p:cNvPr id="1230949354" name="灯片编号占位符 6"/>
           <p:cNvSpPr>
             <a:spLocks noGrp="1"/>
           </p:cNvSpPr>
@@ -528,7 +528,7 @@
       </p:grpSpPr>
       <p:sp>
         <p:nvSpPr>
-          <p:cNvPr id="2096692521" name="Slide Image Placeholder 1"/>
+          <p:cNvPr id="1386374737" name="Slide Image Placeholder 1"/>
           <p:cNvSpPr>
             <a:spLocks noChangeAspect="1" noGrp="1" noRot="1"/>
           </p:cNvSpPr>
@@ -540,7 +540,7 @@
       </p:sp>
       <p:sp>
         <p:nvSpPr>
-          <p:cNvPr id="606587476" name="Notes Placeholder 2"/>
+          <p:cNvPr id="1714964475" name="Notes Placeholder 2"/>
           <p:cNvSpPr>
             <a:spLocks noGrp="1"/>
           </p:cNvSpPr>
@@ -562,7 +562,7 @@
       </p:sp>
       <p:sp>
         <p:nvSpPr>
-          <p:cNvPr id="175662446" name="Slide Number Placeholder 3"/>
+          <p:cNvPr id="1488280346" name="Slide Number Placeholder 3"/>
           <p:cNvSpPr>
             <a:spLocks noGrp="1"/>
           </p:cNvSpPr>
@@ -613,7 +613,7 @@
       </p:grpSpPr>
       <p:sp>
         <p:nvSpPr>
-          <p:cNvPr id="2090550426" name="Slide Image Placeholder 1"/>
+          <p:cNvPr id="729003148" name="Slide Image Placeholder 1"/>
           <p:cNvSpPr>
             <a:spLocks noChangeAspect="1" noGrp="1" noRot="1"/>
           </p:cNvSpPr>
@@ -625,7 +625,7 @@
       </p:sp>
       <p:sp>
         <p:nvSpPr>
-          <p:cNvPr id="785218408" name="Notes Placeholder 2"/>
+          <p:cNvPr id="773708921" name="Notes Placeholder 2"/>
           <p:cNvSpPr>
             <a:spLocks noGrp="1"/>
           </p:cNvSpPr>
@@ -647,7 +647,7 @@
       </p:sp>
       <p:sp>
         <p:nvSpPr>
-          <p:cNvPr id="1096569654" name="Slide Number Placeholder 3"/>
+          <p:cNvPr id="1025268072" name="Slide Number Placeholder 3"/>
           <p:cNvSpPr>
             <a:spLocks noGrp="1"/>
           </p:cNvSpPr>
@@ -698,7 +698,7 @@
       </p:grpSpPr>
       <p:sp>
         <p:nvSpPr>
-          <p:cNvPr id="1916297119" name="Slide Image Placeholder 1"/>
+          <p:cNvPr id="2073401217" name="Slide Image Placeholder 1"/>
           <p:cNvSpPr>
             <a:spLocks noChangeAspect="1" noGrp="1" noRot="1"/>
           </p:cNvSpPr>
@@ -710,7 +710,7 @@
       </p:sp>
       <p:sp>
         <p:nvSpPr>
-          <p:cNvPr id="1422781203" name="Notes Placeholder 2"/>
+          <p:cNvPr id="639833506" name="Notes Placeholder 2"/>
           <p:cNvSpPr>
             <a:spLocks noGrp="1"/>
           </p:cNvSpPr>
@@ -732,7 +732,7 @@
       </p:sp>
       <p:sp>
         <p:nvSpPr>
-          <p:cNvPr id="46593205" name="Slide Number Placeholder 3"/>
+          <p:cNvPr id="719091808" name="Slide Number Placeholder 3"/>
           <p:cNvSpPr>
             <a:spLocks noGrp="1"/>
           </p:cNvSpPr>
@@ -783,7 +783,7 @@
       </p:grpSpPr>
       <p:sp>
         <p:nvSpPr>
-          <p:cNvPr id="1569044604" name="Slide Image Placeholder 1"/>
+          <p:cNvPr id="30112051" name="Slide Image Placeholder 1"/>
           <p:cNvSpPr>
             <a:spLocks noChangeAspect="1" noGrp="1" noRot="1"/>
           </p:cNvSpPr>
@@ -795,7 +795,7 @@
       </p:sp>
       <p:sp>
         <p:nvSpPr>
-          <p:cNvPr id="1348302693" name="Notes Placeholder 2"/>
+          <p:cNvPr id="1253704820" name="Notes Placeholder 2"/>
           <p:cNvSpPr>
             <a:spLocks noGrp="1"/>
           </p:cNvSpPr>
@@ -817,7 +817,7 @@
       </p:sp>
       <p:sp>
         <p:nvSpPr>
-          <p:cNvPr id="1553285533" name="Slide Number Placeholder 3"/>
+          <p:cNvPr id="1176887903" name="Slide Number Placeholder 3"/>
           <p:cNvSpPr>
             <a:spLocks noGrp="1"/>
           </p:cNvSpPr>
@@ -868,7 +868,7 @@
       </p:grpSpPr>
       <p:sp>
         <p:nvSpPr>
-          <p:cNvPr id="578385784" name="Slide Image Placeholder 1"/>
+          <p:cNvPr id="228071322" name="Slide Image Placeholder 1"/>
           <p:cNvSpPr>
             <a:spLocks noChangeAspect="1" noGrp="1" noRot="1"/>
           </p:cNvSpPr>
@@ -880,7 +880,7 @@
       </p:sp>
       <p:sp>
         <p:nvSpPr>
-          <p:cNvPr id="1997681794" name="Notes Placeholder 2"/>
+          <p:cNvPr id="1685049741" name="Notes Placeholder 2"/>
           <p:cNvSpPr>
             <a:spLocks noGrp="1"/>
           </p:cNvSpPr>
@@ -902,7 +902,7 @@
       </p:sp>
       <p:sp>
         <p:nvSpPr>
-          <p:cNvPr id="1570090503" name="Slide Number Placeholder 3"/>
+          <p:cNvPr id="194764421" name="Slide Number Placeholder 3"/>
           <p:cNvSpPr>
             <a:spLocks noGrp="1"/>
           </p:cNvSpPr>
@@ -953,7 +953,7 @@
       </p:grpSpPr>
       <p:sp>
         <p:nvSpPr>
-          <p:cNvPr id="504131895" name="Slide Image Placeholder 1"/>
+          <p:cNvPr id="1164217769" name="Slide Image Placeholder 1"/>
           <p:cNvSpPr>
             <a:spLocks noChangeAspect="1" noGrp="1" noRot="1"/>
           </p:cNvSpPr>
@@ -965,7 +965,7 @@
       </p:sp>
       <p:sp>
         <p:nvSpPr>
-          <p:cNvPr id="1463775847" name="Notes Placeholder 2"/>
+          <p:cNvPr id="422588355" name="Notes Placeholder 2"/>
           <p:cNvSpPr>
             <a:spLocks noGrp="1"/>
           </p:cNvSpPr>
@@ -987,7 +987,7 @@
       </p:sp>
       <p:sp>
         <p:nvSpPr>
-          <p:cNvPr id="605250059" name="Slide Number Placeholder 3"/>
+          <p:cNvPr id="182997102" name="Slide Number Placeholder 3"/>
           <p:cNvSpPr>
             <a:spLocks noGrp="1"/>
           </p:cNvSpPr>
@@ -1038,7 +1038,7 @@
       </p:grpSpPr>
       <p:sp>
         <p:nvSpPr>
-          <p:cNvPr id="1091406042" name="Slide Image Placeholder 1"/>
+          <p:cNvPr id="1596064213" name="Slide Image Placeholder 1"/>
           <p:cNvSpPr>
             <a:spLocks noChangeAspect="1" noGrp="1" noRot="1"/>
           </p:cNvSpPr>
@@ -1050,7 +1050,7 @@
       </p:sp>
       <p:sp>
         <p:nvSpPr>
-          <p:cNvPr id="914266316" name="Notes Placeholder 2"/>
+          <p:cNvPr id="2003717063" name="Notes Placeholder 2"/>
           <p:cNvSpPr>
             <a:spLocks noGrp="1"/>
           </p:cNvSpPr>
@@ -1072,7 +1072,7 @@
       </p:sp>
       <p:sp>
         <p:nvSpPr>
-          <p:cNvPr id="163697077" name="Slide Number Placeholder 3"/>
+          <p:cNvPr id="752761991" name="Slide Number Placeholder 3"/>
           <p:cNvSpPr>
             <a:spLocks noGrp="1"/>
           </p:cNvSpPr>
@@ -1123,7 +1123,7 @@
       </p:grpSpPr>
       <p:sp>
         <p:nvSpPr>
-          <p:cNvPr id="1337736295" name="Slide Image Placeholder 1"/>
+          <p:cNvPr id="882007572" name="Slide Image Placeholder 1"/>
           <p:cNvSpPr>
             <a:spLocks noChangeAspect="1" noGrp="1" noRot="1"/>
           </p:cNvSpPr>
@@ -1135,7 +1135,7 @@
       </p:sp>
       <p:sp>
         <p:nvSpPr>
-          <p:cNvPr id="597068817" name="Notes Placeholder 2"/>
+          <p:cNvPr id="273125625" name="Notes Placeholder 2"/>
           <p:cNvSpPr>
             <a:spLocks noGrp="1"/>
           </p:cNvSpPr>
@@ -1157,7 +1157,7 @@
       </p:sp>
       <p:sp>
         <p:nvSpPr>
-          <p:cNvPr id="400718918" name="Slide Number Placeholder 3"/>
+          <p:cNvPr id="2012382012" name="Slide Number Placeholder 3"/>
           <p:cNvSpPr>
             <a:spLocks noGrp="1"/>
           </p:cNvSpPr>
@@ -1208,7 +1208,7 @@
       </p:grpSpPr>
       <p:sp>
         <p:nvSpPr>
-          <p:cNvPr id="1992902006" name="Slide Image Placeholder 1"/>
+          <p:cNvPr id="668628274" name="Slide Image Placeholder 1"/>
           <p:cNvSpPr>
             <a:spLocks noChangeAspect="1" noGrp="1" noRot="1"/>
           </p:cNvSpPr>
@@ -1220,7 +1220,7 @@
       </p:sp>
       <p:sp>
         <p:nvSpPr>
-          <p:cNvPr id="515283162" name="Notes Placeholder 2"/>
+          <p:cNvPr id="1677239537" name="Notes Placeholder 2"/>
           <p:cNvSpPr>
             <a:spLocks noGrp="1"/>
           </p:cNvSpPr>
@@ -1242,7 +1242,7 @@
       </p:sp>
       <p:sp>
         <p:nvSpPr>
-          <p:cNvPr id="552185226" name="Slide Number Placeholder 3"/>
+          <p:cNvPr id="182390361" name="Slide Number Placeholder 3"/>
           <p:cNvSpPr>
             <a:spLocks noGrp="1"/>
           </p:cNvSpPr>
@@ -1293,7 +1293,7 @@
       </p:grpSpPr>
       <p:sp>
         <p:nvSpPr>
-          <p:cNvPr id="2" name="Slide Image Placeholder 1"/>
+          <p:cNvPr id="284359080" name="Slide Image Placeholder 1"/>
           <p:cNvSpPr>
             <a:spLocks noChangeAspect="1" noGrp="1" noRot="1"/>
           </p:cNvSpPr>
@@ -1305,7 +1305,7 @@
       </p:sp>
       <p:sp>
         <p:nvSpPr>
-          <p:cNvPr id="3" name="Notes Placeholder 2"/>
+          <p:cNvPr id="2077097347" name="Notes Placeholder 2"/>
           <p:cNvSpPr>
             <a:spLocks noGrp="1"/>
           </p:cNvSpPr>
@@ -1327,7 +1327,7 @@
       </p:sp>
       <p:sp>
         <p:nvSpPr>
-          <p:cNvPr id="4" name="Slide Number Placeholder 3"/>
+          <p:cNvPr id="324998989" name="Slide Number Placeholder 3"/>
           <p:cNvSpPr>
             <a:spLocks noGrp="1"/>
           </p:cNvSpPr>
@@ -1378,7 +1378,7 @@
       </p:grpSpPr>
       <p:sp>
         <p:nvSpPr>
-          <p:cNvPr id="555927890" name="Slide Image Placeholder 1"/>
+          <p:cNvPr id="43635112" name="Slide Image Placeholder 1"/>
           <p:cNvSpPr>
             <a:spLocks noChangeAspect="1" noGrp="1" noRot="1"/>
           </p:cNvSpPr>
@@ -1390,7 +1390,7 @@
       </p:sp>
       <p:sp>
         <p:nvSpPr>
-          <p:cNvPr id="1059331583" name="Notes Placeholder 2"/>
+          <p:cNvPr id="1488222181" name="Notes Placeholder 2"/>
           <p:cNvSpPr>
             <a:spLocks noGrp="1"/>
           </p:cNvSpPr>
@@ -1412,7 +1412,7 @@
       </p:sp>
       <p:sp>
         <p:nvSpPr>
-          <p:cNvPr id="1656851494" name="Slide Number Placeholder 3"/>
+          <p:cNvPr id="316317255" name="Slide Number Placeholder 3"/>
           <p:cNvSpPr>
             <a:spLocks noGrp="1"/>
           </p:cNvSpPr>
@@ -1463,7 +1463,7 @@
       </p:grpSpPr>
       <p:sp>
         <p:nvSpPr>
-          <p:cNvPr id="2" name="Slide Image Placeholder 1"/>
+          <p:cNvPr id="1021081947" name="Slide Image Placeholder 1"/>
           <p:cNvSpPr>
             <a:spLocks noChangeAspect="1" noGrp="1" noRot="1"/>
           </p:cNvSpPr>
@@ -1475,7 +1475,7 @@
       </p:sp>
       <p:sp>
         <p:nvSpPr>
-          <p:cNvPr id="3" name="Notes Placeholder 2"/>
+          <p:cNvPr id="1398991814" name="Notes Placeholder 2"/>
           <p:cNvSpPr>
             <a:spLocks noGrp="1"/>
           </p:cNvSpPr>
@@ -1497,7 +1497,7 @@
       </p:sp>
       <p:sp>
         <p:nvSpPr>
-          <p:cNvPr id="4" name="Slide Number Placeholder 3"/>
+          <p:cNvPr id="1405908522" name="Slide Number Placeholder 3"/>
           <p:cNvSpPr>
             <a:spLocks noGrp="1"/>
           </p:cNvSpPr>
@@ -1548,7 +1548,7 @@
       </p:grpSpPr>
       <p:sp>
         <p:nvSpPr>
-          <p:cNvPr id="1764447941" name="Slide Image Placeholder 1"/>
+          <p:cNvPr id="818147122" name="Slide Image Placeholder 1"/>
           <p:cNvSpPr>
             <a:spLocks noChangeAspect="1" noGrp="1" noRot="1"/>
           </p:cNvSpPr>
@@ -1560,7 +1560,7 @@
       </p:sp>
       <p:sp>
         <p:nvSpPr>
-          <p:cNvPr id="1623911160" name="Notes Placeholder 2"/>
+          <p:cNvPr id="1547256055" name="Notes Placeholder 2"/>
           <p:cNvSpPr>
             <a:spLocks noGrp="1"/>
           </p:cNvSpPr>
@@ -1582,7 +1582,7 @@
       </p:sp>
       <p:sp>
         <p:nvSpPr>
-          <p:cNvPr id="1852248743" name="Slide Number Placeholder 3"/>
+          <p:cNvPr id="1352535199" name="Slide Number Placeholder 3"/>
           <p:cNvSpPr>
             <a:spLocks noGrp="1"/>
           </p:cNvSpPr>
@@ -1633,7 +1633,7 @@
       </p:grpSpPr>
       <p:sp>
         <p:nvSpPr>
-          <p:cNvPr id="892099058" name="Slide Image Placeholder 1"/>
+          <p:cNvPr id="2122833494" name="Slide Image Placeholder 1"/>
           <p:cNvSpPr>
             <a:spLocks noChangeAspect="1" noGrp="1" noRot="1"/>
           </p:cNvSpPr>
@@ -1645,7 +1645,7 @@
       </p:sp>
       <p:sp>
         <p:nvSpPr>
-          <p:cNvPr id="46997260" name="Notes Placeholder 2"/>
+          <p:cNvPr id="1393254497" name="Notes Placeholder 2"/>
           <p:cNvSpPr>
             <a:spLocks noGrp="1"/>
           </p:cNvSpPr>
@@ -1667,7 +1667,7 @@
       </p:sp>
       <p:sp>
         <p:nvSpPr>
-          <p:cNvPr id="1919231913" name="Slide Number Placeholder 3"/>
+          <p:cNvPr id="1309259550" name="Slide Number Placeholder 3"/>
           <p:cNvSpPr>
             <a:spLocks noGrp="1"/>
           </p:cNvSpPr>
@@ -1718,7 +1718,7 @@
       </p:grpSpPr>
       <p:sp>
         <p:nvSpPr>
-          <p:cNvPr id="2" name="Slide Image Placeholder 1"/>
+          <p:cNvPr id="457854557" name="Slide Image Placeholder 1"/>
           <p:cNvSpPr>
             <a:spLocks noChangeAspect="1" noGrp="1" noRot="1"/>
           </p:cNvSpPr>
@@ -1730,7 +1730,7 @@
       </p:sp>
       <p:sp>
         <p:nvSpPr>
-          <p:cNvPr id="3" name="Notes Placeholder 2"/>
+          <p:cNvPr id="2054553824" name="Notes Placeholder 2"/>
           <p:cNvSpPr>
             <a:spLocks noGrp="1"/>
           </p:cNvSpPr>
@@ -1752,7 +1752,7 @@
       </p:sp>
       <p:sp>
         <p:nvSpPr>
-          <p:cNvPr id="4" name="Slide Number Placeholder 3"/>
+          <p:cNvPr id="645163167" name="Slide Number Placeholder 3"/>
           <p:cNvSpPr>
             <a:spLocks noGrp="1"/>
           </p:cNvSpPr>
@@ -1803,7 +1803,7 @@
       </p:grpSpPr>
       <p:sp>
         <p:nvSpPr>
-          <p:cNvPr id="2" name="Slide Image Placeholder 1"/>
+          <p:cNvPr id="209093595" name="Slide Image Placeholder 1"/>
           <p:cNvSpPr>
             <a:spLocks noChangeAspect="1" noGrp="1" noRot="1"/>
           </p:cNvSpPr>
@@ -1815,7 +1815,7 @@
       </p:sp>
       <p:sp>
         <p:nvSpPr>
-          <p:cNvPr id="3" name="Notes Placeholder 2"/>
+          <p:cNvPr id="64212315" name="Notes Placeholder 2"/>
           <p:cNvSpPr>
             <a:spLocks noGrp="1"/>
           </p:cNvSpPr>
@@ -1837,7 +1837,7 @@
       </p:sp>
       <p:sp>
         <p:nvSpPr>
-          <p:cNvPr id="4" name="Slide Number Placeholder 3"/>
+          <p:cNvPr id="1815918282" name="Slide Number Placeholder 3"/>
           <p:cNvSpPr>
             <a:spLocks noGrp="1"/>
           </p:cNvSpPr>
@@ -1888,7 +1888,7 @@
       </p:grpSpPr>
       <p:sp>
         <p:nvSpPr>
-          <p:cNvPr id="1623824671" name="Slide Image Placeholder 1"/>
+          <p:cNvPr id="931006398" name="Slide Image Placeholder 1"/>
           <p:cNvSpPr>
             <a:spLocks noChangeAspect="1" noGrp="1" noRot="1"/>
           </p:cNvSpPr>
@@ -1900,7 +1900,7 @@
       </p:sp>
       <p:sp>
         <p:nvSpPr>
-          <p:cNvPr id="1510892997" name="Notes Placeholder 2"/>
+          <p:cNvPr id="1467916405" name="Notes Placeholder 2"/>
           <p:cNvSpPr>
             <a:spLocks noGrp="1"/>
           </p:cNvSpPr>
@@ -1922,7 +1922,7 @@
       </p:sp>
       <p:sp>
         <p:nvSpPr>
-          <p:cNvPr id="1507470522" name="Slide Number Placeholder 3"/>
+          <p:cNvPr id="132598188" name="Slide Number Placeholder 3"/>
           <p:cNvSpPr>
             <a:spLocks noGrp="1"/>
           </p:cNvSpPr>
@@ -1973,7 +1973,7 @@
       </p:grpSpPr>
       <p:sp>
         <p:nvSpPr>
-          <p:cNvPr id="1224901966" name="Slide Image Placeholder 1"/>
+          <p:cNvPr id="328510827" name="Slide Image Placeholder 1"/>
           <p:cNvSpPr>
             <a:spLocks noChangeAspect="1" noGrp="1" noRot="1"/>
           </p:cNvSpPr>
@@ -1985,7 +1985,7 @@
       </p:sp>
       <p:sp>
         <p:nvSpPr>
-          <p:cNvPr id="2061537858" name="Notes Placeholder 2"/>
+          <p:cNvPr id="2017520459" name="Notes Placeholder 2"/>
           <p:cNvSpPr>
             <a:spLocks noGrp="1"/>
           </p:cNvSpPr>
@@ -2007,7 +2007,7 @@
       </p:sp>
       <p:sp>
         <p:nvSpPr>
-          <p:cNvPr id="898062025" name="Slide Number Placeholder 3"/>
+          <p:cNvPr id="803514584" name="Slide Number Placeholder 3"/>
           <p:cNvSpPr>
             <a:spLocks noGrp="1"/>
           </p:cNvSpPr>
@@ -2058,7 +2058,7 @@
       </p:grpSpPr>
       <p:sp>
         <p:nvSpPr>
-          <p:cNvPr id="2" name="Slide Image Placeholder 1"/>
+          <p:cNvPr id="1245392688" name="Slide Image Placeholder 1"/>
           <p:cNvSpPr>
             <a:spLocks noChangeAspect="1" noGrp="1" noRot="1"/>
           </p:cNvSpPr>
@@ -2070,7 +2070,7 @@
       </p:sp>
       <p:sp>
         <p:nvSpPr>
-          <p:cNvPr id="3" name="Notes Placeholder 2"/>
+          <p:cNvPr id="544743830" name="Notes Placeholder 2"/>
           <p:cNvSpPr>
             <a:spLocks noGrp="1"/>
           </p:cNvSpPr>
@@ -2092,7 +2092,7 @@
       </p:sp>
       <p:sp>
         <p:nvSpPr>
-          <p:cNvPr id="4" name="Slide Number Placeholder 3"/>
+          <p:cNvPr id="343881879" name="Slide Number Placeholder 3"/>
           <p:cNvSpPr>
             <a:spLocks noGrp="1"/>
           </p:cNvSpPr>
@@ -2143,7 +2143,7 @@
       </p:grpSpPr>
       <p:sp>
         <p:nvSpPr>
-          <p:cNvPr id="612217930" name="Slide Image Placeholder 1"/>
+          <p:cNvPr id="2010657958" name="Slide Image Placeholder 1"/>
           <p:cNvSpPr>
             <a:spLocks noChangeAspect="1" noGrp="1" noRot="1"/>
           </p:cNvSpPr>
@@ -2155,7 +2155,7 @@
       </p:sp>
       <p:sp>
         <p:nvSpPr>
-          <p:cNvPr id="558803229" name="Notes Placeholder 2"/>
+          <p:cNvPr id="92412766" name="Notes Placeholder 2"/>
           <p:cNvSpPr>
             <a:spLocks noGrp="1"/>
           </p:cNvSpPr>
@@ -2177,7 +2177,7 @@
       </p:sp>
       <p:sp>
         <p:nvSpPr>
-          <p:cNvPr id="1397944028" name="Slide Number Placeholder 3"/>
+          <p:cNvPr id="1688935538" name="Slide Number Placeholder 3"/>
           <p:cNvSpPr>
             <a:spLocks noGrp="1"/>
           </p:cNvSpPr>
@@ -2228,7 +2228,7 @@
       </p:grpSpPr>
       <p:sp>
         <p:nvSpPr>
-          <p:cNvPr id="55714881" name="Slide Image Placeholder 1"/>
+          <p:cNvPr id="1751040250" name="Slide Image Placeholder 1"/>
           <p:cNvSpPr>
             <a:spLocks noChangeAspect="1" noGrp="1" noRot="1"/>
           </p:cNvSpPr>
@@ -2240,7 +2240,7 @@
       </p:sp>
       <p:sp>
         <p:nvSpPr>
-          <p:cNvPr id="1719714264" name="Notes Placeholder 2"/>
+          <p:cNvPr id="294609772" name="Notes Placeholder 2"/>
           <p:cNvSpPr>
             <a:spLocks noGrp="1"/>
           </p:cNvSpPr>
@@ -2262,7 +2262,7 @@
       </p:sp>
       <p:sp>
         <p:nvSpPr>
-          <p:cNvPr id="815059097" name="Slide Number Placeholder 3"/>
+          <p:cNvPr id="2085308012" name="Slide Number Placeholder 3"/>
           <p:cNvSpPr>
             <a:spLocks noGrp="1"/>
           </p:cNvSpPr>
@@ -2313,7 +2313,7 @@
       </p:grpSpPr>
       <p:sp>
         <p:nvSpPr>
-          <p:cNvPr id="1353488867" name="Slide Image Placeholder 1"/>
+          <p:cNvPr id="1217262540" name="Slide Image Placeholder 1"/>
           <p:cNvSpPr>
             <a:spLocks noChangeAspect="1" noGrp="1" noRot="1"/>
           </p:cNvSpPr>
@@ -2325,7 +2325,7 @@
       </p:sp>
       <p:sp>
         <p:nvSpPr>
-          <p:cNvPr id="1873936344" name="Notes Placeholder 2"/>
+          <p:cNvPr id="1368482909" name="Notes Placeholder 2"/>
           <p:cNvSpPr>
             <a:spLocks noGrp="1"/>
           </p:cNvSpPr>
@@ -2347,7 +2347,7 @@
       </p:sp>
       <p:sp>
         <p:nvSpPr>
-          <p:cNvPr id="733652846" name="Slide Number Placeholder 3"/>
+          <p:cNvPr id="680825677" name="Slide Number Placeholder 3"/>
           <p:cNvSpPr>
             <a:spLocks noGrp="1"/>
           </p:cNvSpPr>
@@ -2398,7 +2398,7 @@
       </p:grpSpPr>
       <p:sp>
         <p:nvSpPr>
-          <p:cNvPr id="1250526512" name="Slide Image Placeholder 1"/>
+          <p:cNvPr id="417625843" name="Slide Image Placeholder 1"/>
           <p:cNvSpPr>
             <a:spLocks noChangeAspect="1" noGrp="1" noRot="1"/>
           </p:cNvSpPr>
@@ -2410,7 +2410,7 @@
       </p:sp>
       <p:sp>
         <p:nvSpPr>
-          <p:cNvPr id="885562141" name="Notes Placeholder 2"/>
+          <p:cNvPr id="1536482888" name="Notes Placeholder 2"/>
           <p:cNvSpPr>
             <a:spLocks noGrp="1"/>
           </p:cNvSpPr>
@@ -2432,7 +2432,7 @@
       </p:sp>
       <p:sp>
         <p:nvSpPr>
-          <p:cNvPr id="2043618366" name="Slide Number Placeholder 3"/>
+          <p:cNvPr id="1114729392" name="Slide Number Placeholder 3"/>
           <p:cNvSpPr>
             <a:spLocks noGrp="1"/>
           </p:cNvSpPr>
@@ -2483,7 +2483,7 @@
       </p:grpSpPr>
       <p:sp>
         <p:nvSpPr>
-          <p:cNvPr id="1644629273" name="Slide Image Placeholder 1"/>
+          <p:cNvPr id="1139598805" name="Slide Image Placeholder 1"/>
           <p:cNvSpPr>
             <a:spLocks noChangeAspect="1" noGrp="1" noRot="1"/>
           </p:cNvSpPr>
@@ -2495,7 +2495,7 @@
       </p:sp>
       <p:sp>
         <p:nvSpPr>
-          <p:cNvPr id="1153203485" name="Notes Placeholder 2"/>
+          <p:cNvPr id="1344345985" name="Notes Placeholder 2"/>
           <p:cNvSpPr>
             <a:spLocks noGrp="1"/>
           </p:cNvSpPr>
@@ -2517,7 +2517,7 @@
       </p:sp>
       <p:sp>
         <p:nvSpPr>
-          <p:cNvPr id="1088037256" name="Slide Number Placeholder 3"/>
+          <p:cNvPr id="498355418" name="Slide Number Placeholder 3"/>
           <p:cNvSpPr>
             <a:spLocks noGrp="1"/>
           </p:cNvSpPr>
@@ -2568,7 +2568,7 @@
       </p:grpSpPr>
       <p:sp>
         <p:nvSpPr>
-          <p:cNvPr id="1101182058" name="Slide Image Placeholder 1"/>
+          <p:cNvPr id="2126699611" name="Slide Image Placeholder 1"/>
           <p:cNvSpPr>
             <a:spLocks noChangeAspect="1" noGrp="1" noRot="1"/>
           </p:cNvSpPr>
@@ -2580,7 +2580,7 @@
       </p:sp>
       <p:sp>
         <p:nvSpPr>
-          <p:cNvPr id="1002799380" name="Notes Placeholder 2"/>
+          <p:cNvPr id="295700100" name="Notes Placeholder 2"/>
           <p:cNvSpPr>
             <a:spLocks noGrp="1"/>
           </p:cNvSpPr>
@@ -2602,7 +2602,7 @@
       </p:sp>
       <p:sp>
         <p:nvSpPr>
-          <p:cNvPr id="745603965" name="Slide Number Placeholder 3"/>
+          <p:cNvPr id="1952847908" name="Slide Number Placeholder 3"/>
           <p:cNvSpPr>
             <a:spLocks noGrp="1"/>
           </p:cNvSpPr>
@@ -2653,7 +2653,7 @@
       </p:grpSpPr>
       <p:sp>
         <p:nvSpPr>
-          <p:cNvPr id="1822419333" name="Slide Image Placeholder 1"/>
+          <p:cNvPr id="2117252035" name="Slide Image Placeholder 1"/>
           <p:cNvSpPr>
             <a:spLocks noChangeAspect="1" noGrp="1" noRot="1"/>
           </p:cNvSpPr>
@@ -2665,7 +2665,7 @@
       </p:sp>
       <p:sp>
         <p:nvSpPr>
-          <p:cNvPr id="2126001256" name="Notes Placeholder 2"/>
+          <p:cNvPr id="1645502002" name="Notes Placeholder 2"/>
           <p:cNvSpPr>
             <a:spLocks noGrp="1"/>
           </p:cNvSpPr>
@@ -2687,7 +2687,7 @@
       </p:sp>
       <p:sp>
         <p:nvSpPr>
-          <p:cNvPr id="559622074" name="Slide Number Placeholder 3"/>
+          <p:cNvPr id="1931594287" name="Slide Number Placeholder 3"/>
           <p:cNvSpPr>
             <a:spLocks noGrp="1"/>
           </p:cNvSpPr>
@@ -2763,7 +2763,7 @@
       </p:grpSpPr>
       <p:pic>
         <p:nvPicPr>
-          <p:cNvPr id="404072782" name="图片 1"/>
+          <p:cNvPr id="2128376545" name="图片 1"/>
           <p:cNvPicPr>
             <a:picLocks noChangeAspect="1"/>
           </p:cNvPicPr>
@@ -2786,7 +2786,7 @@
       </p:pic>
       <p:sp>
         <p:nvSpPr>
-          <p:cNvPr id="1975041223" name="矩形 11"/>
+          <p:cNvPr id="918404700" name="矩形 11"/>
           <p:cNvSpPr/>
           <p:nvPr/>
         </p:nvSpPr>
@@ -2864,7 +2864,7 @@
       </p:sp>
       <p:grpSp>
         <p:nvGrpSpPr>
-          <p:cNvPr id="1459406915" name="组合 4"/>
+          <p:cNvPr id="756237943" name="组合 4"/>
           <p:cNvGrpSpPr/>
           <p:nvPr/>
         </p:nvGrpSpPr>
@@ -3108,7 +3108,7 @@
       </p:grpSpPr>
       <p:grpSp>
         <p:nvGrpSpPr>
-          <p:cNvPr id="321530885" name="组合 2"/>
+          <p:cNvPr id="232123988" name="组合 2"/>
           <p:cNvGrpSpPr/>
           <p:nvPr userDrawn="1"/>
         </p:nvGrpSpPr>
@@ -3233,7 +3233,7 @@
       </p:grpSpPr>
       <p:grpSp>
         <p:nvGrpSpPr>
-          <p:cNvPr id="276111535" name="组合 3"/>
+          <p:cNvPr id="1229291772" name="组合 3"/>
           <p:cNvGrpSpPr/>
           <p:nvPr userDrawn="1"/>
         </p:nvGrpSpPr>
@@ -3779,7 +3779,7 @@
       </p:grpSpPr>
       <p:sp>
         <p:nvSpPr>
-          <p:cNvPr id="1402147922" name="椭圆 2"/>
+          <p:cNvPr id="790883867" name="椭圆 2"/>
           <p:cNvSpPr/>
           <p:nvPr/>
         </p:nvSpPr>
@@ -3850,7 +3850,7 @@
       </p:sp>
       <p:sp>
         <p:nvSpPr>
-          <p:cNvPr id="1863845757" name="椭圆 3"/>
+          <p:cNvPr id="1170608742" name="椭圆 3"/>
           <p:cNvSpPr/>
           <p:nvPr/>
         </p:nvSpPr>
@@ -3921,7 +3921,7 @@
       </p:sp>
       <p:sp>
         <p:nvSpPr>
-          <p:cNvPr id="685729226" name="椭圆 4"/>
+          <p:cNvPr id="1855890411" name="椭圆 4"/>
           <p:cNvSpPr/>
           <p:nvPr/>
         </p:nvSpPr>
@@ -3992,7 +3992,7 @@
       </p:sp>
       <p:sp>
         <p:nvSpPr>
-          <p:cNvPr id="1925827243" name="椭圆 6"/>
+          <p:cNvPr id="1331296605" name="椭圆 6"/>
           <p:cNvSpPr/>
           <p:nvPr/>
         </p:nvSpPr>
@@ -4066,7 +4066,7 @@
       </p:sp>
       <p:sp>
         <p:nvSpPr>
-          <p:cNvPr id="289279670" name="椭圆 8"/>
+          <p:cNvPr id="1993229308" name="椭圆 8"/>
           <p:cNvSpPr/>
           <p:nvPr/>
         </p:nvSpPr>
@@ -4137,7 +4137,7 @@
       </p:sp>
       <p:sp>
         <p:nvSpPr>
-          <p:cNvPr id="392430626" name="椭圆 10"/>
+          <p:cNvPr id="1958395187" name="椭圆 10"/>
           <p:cNvSpPr/>
           <p:nvPr/>
         </p:nvSpPr>
@@ -4211,7 +4211,7 @@
       </p:sp>
       <p:sp>
         <p:nvSpPr>
-          <p:cNvPr id="2009132303" name="certification_176902"/>
+          <p:cNvPr id="191436876" name="certification_176902"/>
           <p:cNvSpPr>
             <a:spLocks noChangeAspect="1"/>
           </p:cNvSpPr>
@@ -4785,7 +4785,7 @@
       </p:sp>
       <p:pic>
         <p:nvPicPr>
-          <p:cNvPr id="265932841" name="图片 12"/>
+          <p:cNvPr id="1717941663" name="图片 12"/>
           <p:cNvPicPr>
             <a:picLocks noChangeAspect="1"/>
           </p:cNvPicPr>
@@ -4867,7 +4867,7 @@
       </p:pic>
       <p:sp>
         <p:nvSpPr>
-          <p:cNvPr id="261021284" name=""/>
+          <p:cNvPr id="2757751" name=""/>
           <p:cNvSpPr txBox="1"/>
           <p:nvPr/>
         </p:nvSpPr>
@@ -5029,7 +5029,7 @@
       </p:grpSpPr>
       <p:sp>
         <p:nvSpPr>
-          <p:cNvPr id="1171838738" name=""/>
+          <p:cNvPr id="960588182" name=""/>
           <p:cNvSpPr txBox="1"/>
           <p:nvPr/>
         </p:nvSpPr>
@@ -6455,7 +6455,7 @@
       </p:grpSpPr>
       <p:sp>
         <p:nvSpPr>
-          <p:cNvPr id="1998269281" name=""/>
+          <p:cNvPr id="460244310" name=""/>
           <p:cNvSpPr txBox="1"/>
           <p:nvPr/>
         </p:nvSpPr>
@@ -6833,7 +6833,7 @@
       </p:sp>
       <p:pic>
         <p:nvPicPr>
-          <p:cNvPr id="455781911" name=""/>
+          <p:cNvPr id="1730141164" name=""/>
           <p:cNvPicPr>
             <a:picLocks noChangeAspect="1"/>
           </p:cNvPicPr>
@@ -6888,7 +6888,7 @@
       </p:grpSpPr>
       <p:pic>
         <p:nvPicPr>
-          <p:cNvPr id="478326226" name=""/>
+          <p:cNvPr id="1572024295" name=""/>
           <p:cNvPicPr>
             <a:picLocks noChangeAspect="1"/>
           </p:cNvPicPr>
@@ -6910,7 +6910,7 @@
       </p:pic>
       <p:pic>
         <p:nvPicPr>
-          <p:cNvPr id="1876127529" name=""/>
+          <p:cNvPr id="1454458245" name=""/>
           <p:cNvPicPr>
             <a:picLocks noChangeAspect="1"/>
           </p:cNvPicPr>
@@ -6965,7 +6965,7 @@
       </p:grpSpPr>
       <p:sp>
         <p:nvSpPr>
-          <p:cNvPr id="1702217623" name=""/>
+          <p:cNvPr id="23006492" name=""/>
           <p:cNvSpPr txBox="1"/>
           <p:nvPr/>
         </p:nvSpPr>
@@ -8622,7 +8622,7 @@
       </p:grpSpPr>
       <p:sp>
         <p:nvSpPr>
-          <p:cNvPr id="444183742" name=""/>
+          <p:cNvPr id="721319328" name=""/>
           <p:cNvSpPr txBox="1"/>
           <p:nvPr/>
         </p:nvSpPr>
@@ -10007,7 +10007,7 @@
       </p:grpSpPr>
       <p:sp>
         <p:nvSpPr>
-          <p:cNvPr id="380082194" name=""/>
+          <p:cNvPr id="670393917" name=""/>
           <p:cNvSpPr txBox="1"/>
           <p:nvPr/>
         </p:nvSpPr>
@@ -10899,7 +10899,7 @@
       </p:grpSpPr>
       <p:pic>
         <p:nvPicPr>
-          <p:cNvPr id="580674037" name=""/>
+          <p:cNvPr id="1630729033" name=""/>
           <p:cNvPicPr>
             <a:picLocks noChangeAspect="1"/>
           </p:cNvPicPr>
@@ -10921,7 +10921,7 @@
       </p:pic>
       <p:sp>
         <p:nvSpPr>
-          <p:cNvPr id="1530353805" name=""/>
+          <p:cNvPr id="365033619" name=""/>
           <p:cNvSpPr txBox="1"/>
           <p:nvPr/>
         </p:nvSpPr>
@@ -11131,7 +11131,7 @@
       </p:sp>
       <p:sp>
         <p:nvSpPr>
-          <p:cNvPr id="295231371" name=""/>
+          <p:cNvPr id="478168154" name=""/>
           <p:cNvSpPr txBox="1"/>
           <p:nvPr/>
         </p:nvSpPr>
@@ -11200,7 +11200,7 @@
       </p:grpSpPr>
       <p:sp>
         <p:nvSpPr>
-          <p:cNvPr id="1265991258" name=""/>
+          <p:cNvPr id="152226176" name=""/>
           <p:cNvSpPr txBox="1"/>
           <p:nvPr/>
         </p:nvSpPr>
@@ -11236,7 +11236,7 @@
       </p:sp>
       <p:pic>
         <p:nvPicPr>
-          <p:cNvPr id="375159329" name=""/>
+          <p:cNvPr id="1750587043" name=""/>
           <p:cNvPicPr>
             <a:picLocks noChangeAspect="1"/>
           </p:cNvPicPr>
@@ -11291,7 +11291,7 @@
       </p:grpSpPr>
       <p:sp>
         <p:nvSpPr>
-          <p:cNvPr id="724209765" name=""/>
+          <p:cNvPr id="1678314354" name=""/>
           <p:cNvSpPr txBox="1"/>
           <p:nvPr/>
         </p:nvSpPr>
@@ -11323,7 +11323,7 @@
       </p:sp>
       <p:pic>
         <p:nvPicPr>
-          <p:cNvPr id="252248869" name=""/>
+          <p:cNvPr id="2035161351" name=""/>
           <p:cNvPicPr>
             <a:picLocks noChangeAspect="1"/>
           </p:cNvPicPr>
@@ -11378,7 +11378,7 @@
       </p:grpSpPr>
       <p:sp>
         <p:nvSpPr>
-          <p:cNvPr id="1954849895" name=""/>
+          <p:cNvPr id="1644995767" name=""/>
           <p:cNvSpPr txBox="1"/>
           <p:nvPr/>
         </p:nvSpPr>
@@ -11410,7 +11410,7 @@
       </p:sp>
       <p:pic>
         <p:nvPicPr>
-          <p:cNvPr id="686554650" name=""/>
+          <p:cNvPr id="824512585" name=""/>
           <p:cNvPicPr>
             <a:picLocks noChangeAspect="1"/>
           </p:cNvPicPr>
@@ -11432,7 +11432,7 @@
       </p:pic>
       <p:pic>
         <p:nvPicPr>
-          <p:cNvPr id="1543426880" name=""/>
+          <p:cNvPr id="742858105" name=""/>
           <p:cNvPicPr>
             <a:picLocks noChangeAspect="1"/>
           </p:cNvPicPr>
@@ -11487,7 +11487,7 @@
       </p:grpSpPr>
       <p:pic>
         <p:nvPicPr>
-          <p:cNvPr id="601751338" name=""/>
+          <p:cNvPr id="972269841" name=""/>
           <p:cNvPicPr>
             <a:picLocks noChangeAspect="1"/>
           </p:cNvPicPr>
@@ -11509,7 +11509,7 @@
       </p:pic>
       <p:sp>
         <p:nvSpPr>
-          <p:cNvPr id="1577216507" name=""/>
+          <p:cNvPr id="409343225" name=""/>
           <p:cNvSpPr txBox="1"/>
           <p:nvPr/>
         </p:nvSpPr>
@@ -11581,7 +11581,7 @@
       </p:grpSpPr>
       <p:sp>
         <p:nvSpPr>
-          <p:cNvPr id="2119594613" name=""/>
+          <p:cNvPr id="1307033830" name=""/>
           <p:cNvSpPr txBox="1"/>
           <p:nvPr/>
         </p:nvSpPr>
@@ -12769,7 +12769,7 @@
       </p:sp>
       <p:sp>
         <p:nvSpPr>
-          <p:cNvPr id="268581184" name=""/>
+          <p:cNvPr id="939389825" name=""/>
           <p:cNvSpPr txBox="1"/>
           <p:nvPr/>
         </p:nvSpPr>
@@ -12816,7 +12816,7 @@
       </p:sp>
       <p:pic>
         <p:nvPicPr>
-          <p:cNvPr id="1789979112" name=""/>
+          <p:cNvPr id="120756481" name=""/>
           <p:cNvPicPr>
             <a:picLocks noChangeAspect="1"/>
           </p:cNvPicPr>
@@ -12871,7 +12871,7 @@
       </p:grpSpPr>
       <p:sp>
         <p:nvSpPr>
-          <p:cNvPr id="628210083" name=""/>
+          <p:cNvPr id="1474184264" name=""/>
           <p:cNvSpPr txBox="1"/>
           <p:nvPr/>
         </p:nvSpPr>
@@ -15823,7 +15823,7 @@
       </p:grpSpPr>
       <p:pic>
         <p:nvPicPr>
-          <p:cNvPr id="1305883577" name=""/>
+          <p:cNvPr id="1420649751" name=""/>
           <p:cNvPicPr>
             <a:picLocks noChangeAspect="1"/>
           </p:cNvPicPr>
@@ -15836,7 +15836,7 @@
         <p:spPr bwMode="auto">
           <a:xfrm flipH="0" flipV="0">
             <a:off x="399039" y="904591"/>
-            <a:ext cx="11533187" cy="5354694"/>
+            <a:ext cx="11533186" cy="5354694"/>
           </a:xfrm>
           <a:prstGeom prst="rect">
             <a:avLst/>
@@ -15878,7 +15878,7 @@
       </p:grpSpPr>
       <p:pic>
         <p:nvPicPr>
-          <p:cNvPr id="737295335" name=""/>
+          <p:cNvPr id="410569094" name=""/>
           <p:cNvPicPr>
             <a:picLocks noChangeAspect="1"/>
           </p:cNvPicPr>
@@ -15891,7 +15891,7 @@
         <p:spPr bwMode="auto">
           <a:xfrm flipH="0" flipV="0">
             <a:off x="312448" y="1758042"/>
-            <a:ext cx="11533187" cy="4942794"/>
+            <a:ext cx="11533186" cy="4942794"/>
           </a:xfrm>
           <a:prstGeom prst="rect">
             <a:avLst/>
@@ -15900,7 +15900,7 @@
       </p:pic>
       <p:sp>
         <p:nvSpPr>
-          <p:cNvPr id="880990878" name=""/>
+          <p:cNvPr id="137865196" name=""/>
           <p:cNvSpPr txBox="1"/>
           <p:nvPr/>
         </p:nvSpPr>
@@ -15969,7 +15969,7 @@
       </p:grpSpPr>
       <p:sp>
         <p:nvSpPr>
-          <p:cNvPr id="157925739" name=""/>
+          <p:cNvPr id="263105250" name=""/>
           <p:cNvSpPr txBox="1"/>
           <p:nvPr/>
         </p:nvSpPr>
@@ -15997,14 +15997,14 @@
       </p:sp>
       <p:sp>
         <p:nvSpPr>
-          <p:cNvPr id="1620244462" name=""/>
+          <p:cNvPr id="1127825295" name=""/>
           <p:cNvSpPr txBox="1"/>
           <p:nvPr/>
         </p:nvSpPr>
         <p:spPr bwMode="auto">
           <a:xfrm rot="0" flipH="0" flipV="0">
-            <a:off x="566248" y="1023054"/>
-            <a:ext cx="3388828" cy="3733037"/>
+            <a:off x="566247" y="1023053"/>
+            <a:ext cx="3390267" cy="3733037"/>
           </a:xfrm>
           <a:prstGeom prst="rect">
             <a:avLst/>
@@ -16556,7 +16556,7 @@
       </p:sp>
       <p:pic>
         <p:nvPicPr>
-          <p:cNvPr id="1991722425" name=""/>
+          <p:cNvPr id="1536078217" name=""/>
           <p:cNvPicPr>
             <a:picLocks noChangeAspect="1"/>
           </p:cNvPicPr>
@@ -16611,7 +16611,7 @@
       </p:grpSpPr>
       <p:pic>
         <p:nvPicPr>
-          <p:cNvPr id="1146416787" name=""/>
+          <p:cNvPr id="357742966" name=""/>
           <p:cNvPicPr>
             <a:picLocks noChangeAspect="1"/>
           </p:cNvPicPr>
@@ -16633,7 +16633,7 @@
       </p:pic>
       <p:sp>
         <p:nvSpPr>
-          <p:cNvPr id="659074632" name=""/>
+          <p:cNvPr id="292650522" name=""/>
           <p:cNvSpPr txBox="1"/>
           <p:nvPr/>
         </p:nvSpPr>
@@ -16694,7 +16694,7 @@
       </p:grpSpPr>
       <p:sp>
         <p:nvSpPr>
-          <p:cNvPr id="1763633892" name=""/>
+          <p:cNvPr id="145725085" name=""/>
           <p:cNvSpPr txBox="1"/>
           <p:nvPr/>
         </p:nvSpPr>
@@ -17099,13 +17099,13 @@
       </p:sp>
       <p:graphicFrame>
         <p:nvGraphicFramePr>
-          <p:cNvPr id="1315580634" name=""/>
+          <p:cNvPr id="162732465" name=""/>
           <p:cNvGraphicFramePr>
             <a:graphicFrameLocks xmlns:a="http://schemas.openxmlformats.org/drawingml/2006/main"/>
           </p:cNvGraphicFramePr>
           <p:nvPr/>
         </p:nvGraphicFramePr>
-        <p:xfrm>
+        <p:xfrm rot="0">
           <a:off x="2031999" y="938645"/>
           <a:ext cx="8127999" cy="1525954"/>
         </p:xfrm>
@@ -18041,14 +18041,14 @@
       </p:graphicFrame>
       <p:sp>
         <p:nvSpPr>
-          <p:cNvPr id="972025743" name=""/>
+          <p:cNvPr id="187848321" name=""/>
           <p:cNvSpPr txBox="1"/>
           <p:nvPr/>
         </p:nvSpPr>
         <p:spPr bwMode="auto">
           <a:xfrm rot="0" flipH="0" flipV="0">
-            <a:off x="763772" y="2632226"/>
-            <a:ext cx="11448294" cy="3320555"/>
+            <a:off x="763771" y="2632225"/>
+            <a:ext cx="11449013" cy="3320555"/>
           </a:xfrm>
           <a:prstGeom prst="rect">
             <a:avLst/>
@@ -18233,6 +18233,68 @@
                   <m:oMathPara>
                     <m:oMathParaPr/>
                     <m:oMath>
+                      <m:sSub>
+                        <m:sSubPr>
+                          <m:ctrlPr>
+                            <a:rPr lang="en-US" sz="1800" u="none" strike="noStrike" cap="none" spc="0">
+                              <a:solidFill>
+                                <a:schemeClr val="tx1"/>
+                              </a:solidFill>
+                              <a:latin typeface="Cambria Math"/>
+                              <a:ea typeface="Cambria Math"/>
+                              <a:cs typeface="Cambria Math"/>
+                            </a:rPr>
+                          </m:ctrlPr>
+                        </m:sSubPr>
+                        <m:e>
+                          <m:d>
+                            <m:dPr>
+                              <m:begChr m:val="("/>
+                              <m:endChr m:val=")"/>
+                              <m:ctrlPr>
+                                <a:rPr lang="en-US" sz="1800" u="none" strike="noStrike" cap="none" spc="0">
+                                  <a:solidFill>
+                                    <a:schemeClr val="tx1"/>
+                                  </a:solidFill>
+                                  <a:latin typeface="Cambria Math"/>
+                                  <a:ea typeface="Cambria Math"/>
+                                  <a:cs typeface="Cambria Math"/>
+                                </a:rPr>
+                              </m:ctrlPr>
+                            </m:dPr>
+                            <m:e>
+                              <m:r>
+                                <m:rPr>
+                                  <m:sty m:val="p"/>
+                                </m:rPr>
+                                <a:rPr lang="en-US" sz="1800" u="none" strike="noStrike" cap="none" spc="0">
+                                  <a:solidFill>
+                                    <a:schemeClr val="tx1"/>
+                                  </a:solidFill>
+                                  <a:latin typeface="Cambria Math"/>
+                                  <a:ea typeface="Cambria Math"/>
+                                  <a:cs typeface="Cambria Math"/>
+                                </a:rPr>
+                                <m:t>qBq</m:t>
+                              </m:r>
+                            </m:e>
+                          </m:d>
+                        </m:e>
+                        <m:sub>
+                          <m:r>
+                            <m:rPr/>
+                            <a:rPr lang="en-US" sz="1800" u="none" strike="noStrike" cap="none" spc="0">
+                              <a:solidFill>
+                                <a:schemeClr val="tx1"/>
+                              </a:solidFill>
+                              <a:latin typeface="Cambria Math"/>
+                              <a:ea typeface="Cambria Math"/>
+                              <a:cs typeface="Cambria Math"/>
+                            </a:rPr>
+                            <m:t>k</m:t>
+                          </m:r>
+                        </m:sub>
+                      </m:sSub>
                       <m:r>
                         <m:rPr/>
                         <a:rPr lang="en-US" sz="1800" u="none" strike="noStrike" cap="none" spc="0">
@@ -18451,68 +18513,6 @@
                         </a:rPr>
                         <m:t>)β)</m:t>
                       </m:r>
-                      <m:sSub>
-                        <m:sSubPr>
-                          <m:ctrlPr>
-                            <a:rPr lang="en-US" sz="1800" u="none" strike="noStrike" cap="none" spc="0">
-                              <a:solidFill>
-                                <a:schemeClr val="tx1"/>
-                              </a:solidFill>
-                              <a:latin typeface="Cambria Math"/>
-                              <a:ea typeface="Cambria Math"/>
-                              <a:cs typeface="Cambria Math"/>
-                            </a:rPr>
-                          </m:ctrlPr>
-                        </m:sSubPr>
-                        <m:e>
-                          <m:d>
-                            <m:dPr>
-                              <m:begChr m:val="("/>
-                              <m:endChr m:val=")"/>
-                              <m:ctrlPr>
-                                <a:rPr lang="en-US" sz="1800" u="none" strike="noStrike" cap="none" spc="0">
-                                  <a:solidFill>
-                                    <a:schemeClr val="tx1"/>
-                                  </a:solidFill>
-                                  <a:latin typeface="Cambria Math"/>
-                                  <a:ea typeface="Cambria Math"/>
-                                  <a:cs typeface="Cambria Math"/>
-                                </a:rPr>
-                              </m:ctrlPr>
-                            </m:dPr>
-                            <m:e>
-                              <m:r>
-                                <m:rPr>
-                                  <m:sty m:val="p"/>
-                                </m:rPr>
-                                <a:rPr lang="en-US" sz="1800" u="none" strike="noStrike" cap="none" spc="0">
-                                  <a:solidFill>
-                                    <a:schemeClr val="tx1"/>
-                                  </a:solidFill>
-                                  <a:latin typeface="Cambria Math"/>
-                                  <a:ea typeface="Cambria Math"/>
-                                  <a:cs typeface="Cambria Math"/>
-                                </a:rPr>
-                                <m:t>qBq</m:t>
-                              </m:r>
-                            </m:e>
-                          </m:d>
-                        </m:e>
-                        <m:sub>
-                          <m:r>
-                            <m:rPr/>
-                            <a:rPr lang="en-US" sz="1800" u="none" strike="noStrike" cap="none" spc="0">
-                              <a:solidFill>
-                                <a:schemeClr val="tx1"/>
-                              </a:solidFill>
-                              <a:latin typeface="Cambria Math"/>
-                              <a:ea typeface="Cambria Math"/>
-                              <a:cs typeface="Cambria Math"/>
-                            </a:rPr>
-                            <m:t>k</m:t>
-                          </m:r>
-                        </m:sub>
-                      </m:sSub>
                     </m:oMath>
                   </m:oMathPara>
                 </a14:m>
@@ -18911,7 +18911,7 @@
       </p:sp>
       <p:pic>
         <p:nvPicPr>
-          <p:cNvPr id="1792005871" name=""/>
+          <p:cNvPr id="1362260382" name=""/>
           <p:cNvPicPr>
             <a:picLocks noChangeAspect="1"/>
           </p:cNvPicPr>
@@ -18923,8 +18923,30 @@
         </p:blipFill>
         <p:spPr bwMode="auto">
           <a:xfrm>
-            <a:off x="3415077" y="5075093"/>
+            <a:off x="658812" y="5369501"/>
             <a:ext cx="4895849" cy="1000125"/>
+          </a:xfrm>
+          <a:prstGeom prst="rect">
+            <a:avLst/>
+          </a:prstGeom>
+        </p:spPr>
+      </p:pic>
+      <p:pic>
+        <p:nvPicPr>
+          <p:cNvPr id="1391552335" name=""/>
+          <p:cNvPicPr>
+            <a:picLocks noChangeAspect="1"/>
+          </p:cNvPicPr>
+          <p:nvPr/>
+        </p:nvPicPr>
+        <p:blipFill rotWithShape="1">
+          <a:blip r:embed="rId4"/>
+          <a:stretch/>
+        </p:blipFill>
+        <p:spPr bwMode="auto">
+          <a:xfrm flipH="0" flipV="0">
+            <a:off x="5820681" y="4905999"/>
+            <a:ext cx="6183565" cy="1549785"/>
           </a:xfrm>
           <a:prstGeom prst="rect">
             <a:avLst/>
@@ -18966,7 +18988,7 @@
       </p:grpSpPr>
       <p:sp>
         <p:nvSpPr>
-          <p:cNvPr id="1585472831" name=""/>
+          <p:cNvPr id="516341892" name=""/>
           <p:cNvSpPr txBox="1"/>
           <p:nvPr/>
         </p:nvSpPr>
@@ -19232,7 +19254,7 @@
       </p:sp>
       <p:sp>
         <p:nvSpPr>
-          <p:cNvPr id="1253436013" name=""/>
+          <p:cNvPr id="2096514055" name=""/>
           <p:cNvSpPr txBox="1"/>
           <p:nvPr/>
         </p:nvSpPr>
@@ -19271,7 +19293,7 @@
       </p:sp>
       <p:pic>
         <p:nvPicPr>
-          <p:cNvPr id="263704281" name=""/>
+          <p:cNvPr id="1716501889" name=""/>
           <p:cNvPicPr>
             <a:picLocks noChangeAspect="1"/>
           </p:cNvPicPr>
@@ -19293,7 +19315,7 @@
       </p:pic>
       <p:pic>
         <p:nvPicPr>
-          <p:cNvPr id="921808898" name=""/>
+          <p:cNvPr id="1554366986" name=""/>
           <p:cNvPicPr>
             <a:picLocks noChangeAspect="1"/>
           </p:cNvPicPr>
@@ -19348,7 +19370,7 @@
       </p:grpSpPr>
       <p:sp>
         <p:nvSpPr>
-          <p:cNvPr id="1073524585" name=""/>
+          <p:cNvPr id="51551368" name=""/>
           <p:cNvSpPr txBox="1"/>
           <p:nvPr/>
         </p:nvSpPr>
@@ -20024,7 +20046,7 @@
       </p:sp>
       <p:pic>
         <p:nvPicPr>
-          <p:cNvPr id="542195676" name=""/>
+          <p:cNvPr id="1135471469" name=""/>
           <p:cNvPicPr>
             <a:picLocks noChangeAspect="1"/>
           </p:cNvPicPr>
@@ -20079,7 +20101,7 @@
       </p:grpSpPr>
       <p:sp>
         <p:nvSpPr>
-          <p:cNvPr id="1477786930" name=""/>
+          <p:cNvPr id="262179846" name=""/>
           <p:cNvSpPr txBox="1"/>
           <p:nvPr/>
         </p:nvSpPr>
@@ -20127,7 +20149,7 @@
       </p:sp>
       <p:sp>
         <p:nvSpPr>
-          <p:cNvPr id="1620401383" name=""/>
+          <p:cNvPr id="257977442" name=""/>
           <p:cNvSpPr txBox="1"/>
           <p:nvPr/>
         </p:nvSpPr>
@@ -21843,7 +21865,7 @@
       </p:grpSpPr>
       <p:sp>
         <p:nvSpPr>
-          <p:cNvPr id="1849537497" name=""/>
+          <p:cNvPr id="1758286428" name=""/>
           <p:cNvSpPr txBox="1"/>
           <p:nvPr/>
         </p:nvSpPr>
@@ -21871,7 +21893,7 @@
       </p:sp>
       <p:graphicFrame>
         <p:nvGraphicFramePr>
-          <p:cNvPr id="1809814342" name=""/>
+          <p:cNvPr id="1307509191" name=""/>
           <p:cNvGraphicFramePr>
             <a:graphicFrameLocks xmlns:a="http://schemas.openxmlformats.org/drawingml/2006/main"/>
           </p:cNvGraphicFramePr>
@@ -22720,7 +22742,7 @@
       </p:graphicFrame>
       <p:sp>
         <p:nvSpPr>
-          <p:cNvPr id="1292378998" name=""/>
+          <p:cNvPr id="464034330" name=""/>
           <p:cNvSpPr txBox="1"/>
           <p:nvPr/>
         </p:nvSpPr>
@@ -23267,7 +23289,7 @@
       </p:grpSpPr>
       <p:pic>
         <p:nvPicPr>
-          <p:cNvPr id="1939862654" name=""/>
+          <p:cNvPr id="566128303" name=""/>
           <p:cNvPicPr>
             <a:picLocks noChangeAspect="1"/>
           </p:cNvPicPr>
@@ -23322,7 +23344,7 @@
       </p:grpSpPr>
       <p:pic>
         <p:nvPicPr>
-          <p:cNvPr id="1068677991" name=""/>
+          <p:cNvPr id="1750233885" name=""/>
           <p:cNvPicPr>
             <a:picLocks noChangeAspect="1"/>
           </p:cNvPicPr>
@@ -23377,7 +23399,7 @@
       </p:grpSpPr>
       <p:sp>
         <p:nvSpPr>
-          <p:cNvPr id="118599689" name=""/>
+          <p:cNvPr id="426939007" name=""/>
           <p:cNvSpPr txBox="1"/>
           <p:nvPr/>
         </p:nvSpPr>
@@ -23443,7 +23465,7 @@
       </p:sp>
       <p:sp>
         <p:nvSpPr>
-          <p:cNvPr id="2070783522" name=""/>
+          <p:cNvPr id="1639742504" name=""/>
           <p:cNvSpPr txBox="1"/>
           <p:nvPr/>
         </p:nvSpPr>
@@ -23471,7 +23493,7 @@
       </p:sp>
       <p:sp>
         <p:nvSpPr>
-          <p:cNvPr id="932006466" name=""/>
+          <p:cNvPr id="1471232365" name=""/>
           <p:cNvSpPr txBox="1"/>
           <p:nvPr/>
         </p:nvSpPr>

</xml_diff>